<commit_message>
Add TPM input web form with per-project storage
TPMs pick their project and enter Test Equipment Status and Support
Required in an HTML form served by Apps Script. Input is stored per
project in TPM_Equipment / TPM_Support, and the deck generator now
fills project, release and equipment rows from it.

Co-Authored-By: Claude Opus 5.5 <noreply@anthropic.com>
Claude-Session: https://claude.ai/code/session_01FVar2kDna2r53K7oZGqcAu
</commit_message>
<xml_diff>
--- a/sys-val-dashboard/SYS_VAL_Dashboard_Template.pptx
+++ b/sys-val-dashboard/SYS_VAL_Dashboard_Template.pptx
@@ -3127,7 +3127,7 @@
           </a:fontRef>
         </p:style>
         <p:txBody>
-          <a:bodyPr rtlCol="0" anchor="ctr" wrap="square" lIns="45720" rIns="45720" tIns="18288" bIns="18288"/>
+          <a:bodyPr rtlCol="0" anchor="ctr" wrap="none" lIns="45720" rIns="45720" tIns="18288" bIns="18288"/>
           <a:lstStyle/>
           <a:p>
             <a:pPr algn="ctr"/>
@@ -3138,7 +3138,7 @@
                 </a:solidFill>
                 <a:latin typeface="Arial"/>
               </a:rPr>
-              <a:t>Project A</a:t>
+              <a:t>{{PROJECT}}</a:t>
             </a:r>
           </a:p>
         </p:txBody>
@@ -3215,7 +3215,7 @@
           <a:noFill/>
         </p:spPr>
         <p:txBody>
-          <a:bodyPr wrap="square" anchor="ctr" lIns="45720" rIns="45720" tIns="18288" bIns="18288">
+          <a:bodyPr wrap="none" anchor="ctr" lIns="45720" rIns="45720" tIns="18288" bIns="18288">
             <a:spAutoFit/>
           </a:bodyPr>
           <a:lstStyle/>
@@ -3228,7 +3228,7 @@
                 </a:solidFill>
                 <a:latin typeface="Arial"/>
               </a:rPr>
-              <a:t>SYS VAL PROJECT DASHBOARD REL R250</a:t>
+              <a:t>SYS VAL PROJECT DASHBOARD REL {{RELEASE}}</a:t>
             </a:r>
           </a:p>
         </p:txBody>
@@ -3358,8 +3358,8 @@
           <p:nvPr/>
         </p:nvGraphicFramePr>
         <p:xfrm>
-          <a:off x="441461" y="1644189"/>
-          <a:ext cx="2575191" cy="1846104"/>
+          <a:off x="441461" y="1629766"/>
+          <a:ext cx="2575191" cy="1889370"/>
         </p:xfrm>
         <a:graphic>
           <a:graphicData uri="http://schemas.openxmlformats.org/drawingml/2006/table">
@@ -3373,10 +3373,10 @@
                 <a:gridCol w="588615"/>
                 <a:gridCol w="588615"/>
               </a:tblGrid>
-              <a:tr h="230763">
+              <a:tr h="209930">
                 <a:tc>
                   <a:txBody>
-                    <a:bodyPr/>
+                    <a:bodyPr wrap="none"/>
                     <a:lstStyle/>
                     <a:p>
                       <a:pPr algn="ctr"/>
@@ -3399,7 +3399,7 @@
                 </a:tc>
                 <a:tc>
                   <a:txBody>
-                    <a:bodyPr/>
+                    <a:bodyPr wrap="none"/>
                     <a:lstStyle/>
                     <a:p>
                       <a:pPr algn="ctr"/>
@@ -3410,7 +3410,7 @@
                           </a:solidFill>
                           <a:latin typeface="Arial"/>
                         </a:rPr>
-                        <a:t>Planned Date</a:t>
+                        <a:t>Planned</a:t>
                       </a:r>
                     </a:p>
                   </a:txBody>
@@ -3422,7 +3422,7 @@
                 </a:tc>
                 <a:tc>
                   <a:txBody>
-                    <a:bodyPr/>
+                    <a:bodyPr wrap="none"/>
                     <a:lstStyle/>
                     <a:p>
                       <a:pPr algn="ctr"/>
@@ -3433,7 +3433,7 @@
                           </a:solidFill>
                           <a:latin typeface="Arial"/>
                         </a:rPr>
-                        <a:t>Achieved Date</a:t>
+                        <a:t>Achieved</a:t>
                       </a:r>
                     </a:p>
                   </a:txBody>
@@ -3445,7 +3445,7 @@
                 </a:tc>
                 <a:tc>
                   <a:txBody>
-                    <a:bodyPr/>
+                    <a:bodyPr wrap="none"/>
                     <a:lstStyle/>
                     <a:p>
                       <a:pPr algn="ctr"/>
@@ -3467,21 +3467,21 @@
                   </a:tcPr>
                 </a:tc>
               </a:tr>
-              <a:tr h="230763">
+              <a:tr h="209930">
                 <a:tc>
                   <a:txBody>
-                    <a:bodyPr/>
+                    <a:bodyPr wrap="none"/>
                     <a:lstStyle/>
                     <a:p>
                       <a:pPr algn="ctr"/>
                       <a:r>
-                        <a:rPr sz="800" b="1">
+                        <a:rPr sz="600" b="1">
                           <a:solidFill>
                             <a:srgbClr val="13222D"/>
                           </a:solidFill>
                           <a:latin typeface="Arial"/>
                         </a:rPr>
-                        <a:t>Veh 1</a:t>
+                        <a:t>{{EQ_PLATFORM_1}}</a:t>
                       </a:r>
                     </a:p>
                   </a:txBody>
@@ -3493,18 +3493,18 @@
                 </a:tc>
                 <a:tc>
                   <a:txBody>
-                    <a:bodyPr/>
+                    <a:bodyPr wrap="none"/>
                     <a:lstStyle/>
                     <a:p>
                       <a:pPr algn="ctr"/>
                       <a:r>
-                        <a:rPr sz="800" b="0">
+                        <a:rPr sz="600" b="0">
                           <a:solidFill>
                             <a:srgbClr val="13222D"/>
                           </a:solidFill>
                           <a:latin typeface="Arial"/>
                         </a:rPr>
-                        <a:t>cw43</a:t>
+                        <a:t>{{EQ_PLANNED_1}}</a:t>
                       </a:r>
                     </a:p>
                   </a:txBody>
@@ -3516,18 +3516,18 @@
                 </a:tc>
                 <a:tc>
                   <a:txBody>
-                    <a:bodyPr/>
+                    <a:bodyPr wrap="none"/>
                     <a:lstStyle/>
                     <a:p>
                       <a:pPr algn="ctr"/>
                       <a:r>
-                        <a:rPr sz="800" b="0">
+                        <a:rPr sz="600" b="0">
                           <a:solidFill>
                             <a:srgbClr val="13222D"/>
                           </a:solidFill>
                           <a:latin typeface="Arial"/>
                         </a:rPr>
-                        <a:t>cw50</a:t>
+                        <a:t>{{EQ_ACHIEVED_1}}</a:t>
                       </a:r>
                     </a:p>
                   </a:txBody>
@@ -3539,43 +3539,43 @@
                 </a:tc>
                 <a:tc>
                   <a:txBody>
-                    <a:bodyPr/>
+                    <a:bodyPr wrap="none"/>
                     <a:lstStyle/>
                     <a:p>
                       <a:pPr algn="ctr"/>
                       <a:r>
-                        <a:rPr sz="800" b="1">
+                        <a:rPr sz="600" b="1">
                           <a:solidFill>
                             <a:srgbClr val="13222D"/>
                           </a:solidFill>
                           <a:latin typeface="Arial"/>
                         </a:rPr>
-                        <a:t>Ready</a:t>
+                        <a:t>{{EQ_STATUS_1}}</a:t>
                       </a:r>
                     </a:p>
                   </a:txBody>
                   <a:tcPr anchor="ctr" marL="27432" marR="27432" marT="9144" marB="9144">
                     <a:solidFill>
-                      <a:srgbClr val="92D050"/>
+                      <a:srgbClr val="FFFFFF"/>
                     </a:solidFill>
                   </a:tcPr>
                 </a:tc>
               </a:tr>
-              <a:tr h="230763">
+              <a:tr h="209930">
                 <a:tc>
                   <a:txBody>
-                    <a:bodyPr/>
+                    <a:bodyPr wrap="none"/>
                     <a:lstStyle/>
                     <a:p>
                       <a:pPr algn="ctr"/>
                       <a:r>
-                        <a:rPr sz="800" b="1">
+                        <a:rPr sz="600" b="1">
                           <a:solidFill>
                             <a:srgbClr val="13222D"/>
                           </a:solidFill>
                           <a:latin typeface="Arial"/>
                         </a:rPr>
-                        <a:t>Veh 2</a:t>
+                        <a:t>{{EQ_PLATFORM_2}}</a:t>
                       </a:r>
                     </a:p>
                   </a:txBody>
@@ -3587,18 +3587,18 @@
                 </a:tc>
                 <a:tc>
                   <a:txBody>
-                    <a:bodyPr/>
+                    <a:bodyPr wrap="none"/>
                     <a:lstStyle/>
                     <a:p>
                       <a:pPr algn="ctr"/>
                       <a:r>
-                        <a:rPr sz="800" b="0">
+                        <a:rPr sz="600" b="0">
                           <a:solidFill>
                             <a:srgbClr val="13222D"/>
                           </a:solidFill>
                           <a:latin typeface="Arial"/>
                         </a:rPr>
-                        <a:t>cw46/25</a:t>
+                        <a:t>{{EQ_PLANNED_2}}</a:t>
                       </a:r>
                     </a:p>
                   </a:txBody>
@@ -3610,18 +3610,18 @@
                 </a:tc>
                 <a:tc>
                   <a:txBody>
-                    <a:bodyPr/>
+                    <a:bodyPr wrap="none"/>
                     <a:lstStyle/>
                     <a:p>
                       <a:pPr algn="ctr"/>
                       <a:r>
-                        <a:rPr sz="800" b="0">
+                        <a:rPr sz="600" b="0">
                           <a:solidFill>
                             <a:srgbClr val="13222D"/>
                           </a:solidFill>
                           <a:latin typeface="Arial"/>
                         </a:rPr>
-                        <a:t>cw33/26</a:t>
+                        <a:t>{{EQ_ACHIEVED_2}}</a:t>
                       </a:r>
                     </a:p>
                   </a:txBody>
@@ -3633,43 +3633,43 @@
                 </a:tc>
                 <a:tc>
                   <a:txBody>
-                    <a:bodyPr/>
+                    <a:bodyPr wrap="none"/>
                     <a:lstStyle/>
                     <a:p>
                       <a:pPr algn="ctr"/>
                       <a:r>
-                        <a:rPr sz="800" b="1">
+                        <a:rPr sz="600" b="1">
                           <a:solidFill>
                             <a:srgbClr val="13222D"/>
                           </a:solidFill>
                           <a:latin typeface="Arial"/>
                         </a:rPr>
-                        <a:t>Ready</a:t>
+                        <a:t>{{EQ_STATUS_2}}</a:t>
                       </a:r>
                     </a:p>
                   </a:txBody>
                   <a:tcPr anchor="ctr" marL="27432" marR="27432" marT="9144" marB="9144">
                     <a:solidFill>
-                      <a:srgbClr val="92D050"/>
+                      <a:srgbClr val="FFFFFF"/>
                     </a:solidFill>
                   </a:tcPr>
                 </a:tc>
               </a:tr>
-              <a:tr h="230763">
+              <a:tr h="209930">
                 <a:tc>
                   <a:txBody>
-                    <a:bodyPr/>
+                    <a:bodyPr wrap="none"/>
                     <a:lstStyle/>
                     <a:p>
                       <a:pPr algn="ctr"/>
                       <a:r>
-                        <a:rPr sz="800" b="1">
+                        <a:rPr sz="600" b="1">
                           <a:solidFill>
                             <a:srgbClr val="13222D"/>
                           </a:solidFill>
                           <a:latin typeface="Arial"/>
                         </a:rPr>
-                        <a:t>SYS.5 Bench</a:t>
+                        <a:t>{{EQ_PLATFORM_3}}</a:t>
                       </a:r>
                     </a:p>
                   </a:txBody>
@@ -3681,18 +3681,18 @@
                 </a:tc>
                 <a:tc>
                   <a:txBody>
-                    <a:bodyPr/>
+                    <a:bodyPr wrap="none"/>
                     <a:lstStyle/>
                     <a:p>
                       <a:pPr algn="ctr"/>
                       <a:r>
-                        <a:rPr sz="800" b="0">
+                        <a:rPr sz="600" b="0">
                           <a:solidFill>
                             <a:srgbClr val="13222D"/>
                           </a:solidFill>
                           <a:latin typeface="Arial"/>
                         </a:rPr>
-                        <a:t>cw40</a:t>
+                        <a:t>{{EQ_PLANNED_3}}</a:t>
                       </a:r>
                     </a:p>
                   </a:txBody>
@@ -3704,18 +3704,18 @@
                 </a:tc>
                 <a:tc>
                   <a:txBody>
-                    <a:bodyPr/>
+                    <a:bodyPr wrap="none"/>
                     <a:lstStyle/>
                     <a:p>
                       <a:pPr algn="ctr"/>
                       <a:r>
-                        <a:rPr sz="800" b="0">
+                        <a:rPr sz="600" b="0">
                           <a:solidFill>
                             <a:srgbClr val="13222D"/>
                           </a:solidFill>
                           <a:latin typeface="Arial"/>
                         </a:rPr>
-                        <a:t>cw40</a:t>
+                        <a:t>{{EQ_ACHIEVED_3}}</a:t>
                       </a:r>
                     </a:p>
                   </a:txBody>
@@ -3727,43 +3727,43 @@
                 </a:tc>
                 <a:tc>
                   <a:txBody>
-                    <a:bodyPr/>
+                    <a:bodyPr wrap="none"/>
                     <a:lstStyle/>
                     <a:p>
                       <a:pPr algn="ctr"/>
                       <a:r>
-                        <a:rPr sz="800" b="1">
+                        <a:rPr sz="600" b="1">
                           <a:solidFill>
                             <a:srgbClr val="13222D"/>
                           </a:solidFill>
                           <a:latin typeface="Arial"/>
                         </a:rPr>
-                        <a:t>Ready</a:t>
+                        <a:t>{{EQ_STATUS_3}}</a:t>
                       </a:r>
                     </a:p>
                   </a:txBody>
                   <a:tcPr anchor="ctr" marL="27432" marR="27432" marT="9144" marB="9144">
                     <a:solidFill>
-                      <a:srgbClr val="92D050"/>
+                      <a:srgbClr val="FFFFFF"/>
                     </a:solidFill>
                   </a:tcPr>
                 </a:tc>
               </a:tr>
-              <a:tr h="230763">
+              <a:tr h="209930">
                 <a:tc>
                   <a:txBody>
-                    <a:bodyPr/>
+                    <a:bodyPr wrap="none"/>
                     <a:lstStyle/>
                     <a:p>
                       <a:pPr algn="ctr"/>
                       <a:r>
-                        <a:rPr sz="800" b="1">
+                        <a:rPr sz="600" b="1">
                           <a:solidFill>
                             <a:srgbClr val="13222D"/>
                           </a:solidFill>
                           <a:latin typeface="Arial"/>
                         </a:rPr>
-                        <a:t>SYS.4 Bench 1</a:t>
+                        <a:t>{{EQ_PLATFORM_4}}</a:t>
                       </a:r>
                     </a:p>
                   </a:txBody>
@@ -3775,18 +3775,18 @@
                 </a:tc>
                 <a:tc>
                   <a:txBody>
-                    <a:bodyPr/>
+                    <a:bodyPr wrap="none"/>
                     <a:lstStyle/>
                     <a:p>
                       <a:pPr algn="ctr"/>
                       <a:r>
-                        <a:rPr sz="800" b="0">
+                        <a:rPr sz="600" b="0">
                           <a:solidFill>
                             <a:srgbClr val="13222D"/>
                           </a:solidFill>
                           <a:latin typeface="Arial"/>
                         </a:rPr>
-                        <a:t>cw37</a:t>
+                        <a:t>{{EQ_PLANNED_4}}</a:t>
                       </a:r>
                     </a:p>
                   </a:txBody>
@@ -3798,18 +3798,18 @@
                 </a:tc>
                 <a:tc>
                   <a:txBody>
-                    <a:bodyPr/>
+                    <a:bodyPr wrap="none"/>
                     <a:lstStyle/>
                     <a:p>
                       <a:pPr algn="ctr"/>
                       <a:r>
-                        <a:rPr sz="800" b="0">
+                        <a:rPr sz="600" b="0">
                           <a:solidFill>
                             <a:srgbClr val="13222D"/>
                           </a:solidFill>
                           <a:latin typeface="Arial"/>
                         </a:rPr>
-                        <a:t>cw37</a:t>
+                        <a:t>{{EQ_ACHIEVED_4}}</a:t>
                       </a:r>
                     </a:p>
                   </a:txBody>
@@ -3821,43 +3821,43 @@
                 </a:tc>
                 <a:tc>
                   <a:txBody>
-                    <a:bodyPr/>
+                    <a:bodyPr wrap="none"/>
                     <a:lstStyle/>
                     <a:p>
                       <a:pPr algn="ctr"/>
                       <a:r>
-                        <a:rPr sz="800" b="1">
+                        <a:rPr sz="600" b="1">
                           <a:solidFill>
                             <a:srgbClr val="13222D"/>
                           </a:solidFill>
                           <a:latin typeface="Arial"/>
                         </a:rPr>
-                        <a:t>Ready</a:t>
+                        <a:t>{{EQ_STATUS_4}}</a:t>
                       </a:r>
                     </a:p>
                   </a:txBody>
                   <a:tcPr anchor="ctr" marL="27432" marR="27432" marT="9144" marB="9144">
                     <a:solidFill>
-                      <a:srgbClr val="92D050"/>
+                      <a:srgbClr val="FFFFFF"/>
                     </a:solidFill>
                   </a:tcPr>
                 </a:tc>
               </a:tr>
-              <a:tr h="230763">
+              <a:tr h="209930">
                 <a:tc>
                   <a:txBody>
-                    <a:bodyPr/>
+                    <a:bodyPr wrap="none"/>
                     <a:lstStyle/>
                     <a:p>
                       <a:pPr algn="ctr"/>
                       <a:r>
-                        <a:rPr sz="800" b="1">
+                        <a:rPr sz="600" b="1">
                           <a:solidFill>
                             <a:srgbClr val="13222D"/>
                           </a:solidFill>
                           <a:latin typeface="Arial"/>
                         </a:rPr>
-                        <a:t>CS Bench 1</a:t>
+                        <a:t>{{EQ_PLATFORM_5}}</a:t>
                       </a:r>
                     </a:p>
                   </a:txBody>
@@ -3869,18 +3869,18 @@
                 </a:tc>
                 <a:tc>
                   <a:txBody>
-                    <a:bodyPr/>
+                    <a:bodyPr wrap="none"/>
                     <a:lstStyle/>
                     <a:p>
                       <a:pPr algn="ctr"/>
                       <a:r>
-                        <a:rPr sz="800" b="0">
+                        <a:rPr sz="600" b="0">
                           <a:solidFill>
                             <a:srgbClr val="13222D"/>
                           </a:solidFill>
                           <a:latin typeface="Arial"/>
                         </a:rPr>
-                        <a:t>cw40</a:t>
+                        <a:t>{{EQ_PLANNED_5}}</a:t>
                       </a:r>
                     </a:p>
                   </a:txBody>
@@ -3892,18 +3892,18 @@
                 </a:tc>
                 <a:tc>
                   <a:txBody>
-                    <a:bodyPr/>
+                    <a:bodyPr wrap="none"/>
                     <a:lstStyle/>
                     <a:p>
                       <a:pPr algn="ctr"/>
                       <a:r>
-                        <a:rPr sz="800" b="0">
+                        <a:rPr sz="600" b="0">
                           <a:solidFill>
                             <a:srgbClr val="13222D"/>
                           </a:solidFill>
                           <a:latin typeface="Arial"/>
                         </a:rPr>
-                        <a:t>cw40</a:t>
+                        <a:t>{{EQ_ACHIEVED_5}}</a:t>
                       </a:r>
                     </a:p>
                   </a:txBody>
@@ -3915,43 +3915,43 @@
                 </a:tc>
                 <a:tc>
                   <a:txBody>
-                    <a:bodyPr/>
+                    <a:bodyPr wrap="none"/>
                     <a:lstStyle/>
                     <a:p>
                       <a:pPr algn="ctr"/>
                       <a:r>
-                        <a:rPr sz="800" b="1">
+                        <a:rPr sz="600" b="1">
                           <a:solidFill>
                             <a:srgbClr val="13222D"/>
                           </a:solidFill>
                           <a:latin typeface="Arial"/>
                         </a:rPr>
-                        <a:t>Ready</a:t>
+                        <a:t>{{EQ_STATUS_5}}</a:t>
                       </a:r>
                     </a:p>
                   </a:txBody>
                   <a:tcPr anchor="ctr" marL="27432" marR="27432" marT="9144" marB="9144">
                     <a:solidFill>
-                      <a:srgbClr val="92D050"/>
+                      <a:srgbClr val="FFFFFF"/>
                     </a:solidFill>
                   </a:tcPr>
                 </a:tc>
               </a:tr>
-              <a:tr h="230763">
+              <a:tr h="209930">
                 <a:tc>
                   <a:txBody>
-                    <a:bodyPr/>
+                    <a:bodyPr wrap="none"/>
                     <a:lstStyle/>
                     <a:p>
                       <a:pPr algn="ctr"/>
                       <a:r>
-                        <a:rPr sz="800" b="1">
+                        <a:rPr sz="600" b="1">
                           <a:solidFill>
                             <a:srgbClr val="13222D"/>
                           </a:solidFill>
                           <a:latin typeface="Arial"/>
                         </a:rPr>
-                        <a:t>Cluster HIL</a:t>
+                        <a:t>{{EQ_PLATFORM_6}}</a:t>
                       </a:r>
                     </a:p>
                   </a:txBody>
@@ -3963,18 +3963,18 @@
                 </a:tc>
                 <a:tc>
                   <a:txBody>
-                    <a:bodyPr/>
+                    <a:bodyPr wrap="none"/>
                     <a:lstStyle/>
                     <a:p>
                       <a:pPr algn="ctr"/>
                       <a:r>
-                        <a:rPr sz="800" b="0">
+                        <a:rPr sz="600" b="0">
                           <a:solidFill>
                             <a:srgbClr val="13222D"/>
                           </a:solidFill>
                           <a:latin typeface="Arial"/>
                         </a:rPr>
-                        <a:t>cw32/26</a:t>
+                        <a:t>{{EQ_PLANNED_6}}</a:t>
                       </a:r>
                     </a:p>
                   </a:txBody>
@@ -3986,18 +3986,18 @@
                 </a:tc>
                 <a:tc>
                   <a:txBody>
-                    <a:bodyPr/>
+                    <a:bodyPr wrap="none"/>
                     <a:lstStyle/>
                     <a:p>
                       <a:pPr algn="ctr"/>
                       <a:r>
-                        <a:rPr sz="800" b="0">
+                        <a:rPr sz="600" b="0">
                           <a:solidFill>
                             <a:srgbClr val="13222D"/>
                           </a:solidFill>
                           <a:latin typeface="Arial"/>
                         </a:rPr>
-                        <a:t>cw06/27</a:t>
+                        <a:t>{{EQ_ACHIEVED_6}}</a:t>
                       </a:r>
                     </a:p>
                   </a:txBody>
@@ -4009,43 +4009,43 @@
                 </a:tc>
                 <a:tc>
                   <a:txBody>
-                    <a:bodyPr/>
+                    <a:bodyPr wrap="none"/>
                     <a:lstStyle/>
                     <a:p>
                       <a:pPr algn="ctr"/>
                       <a:r>
-                        <a:rPr sz="800" b="1">
+                        <a:rPr sz="600" b="1">
                           <a:solidFill>
                             <a:srgbClr val="13222D"/>
                           </a:solidFill>
                           <a:latin typeface="Arial"/>
                         </a:rPr>
-                        <a:t>Evaluation</a:t>
+                        <a:t>{{EQ_STATUS_6}}</a:t>
                       </a:r>
                     </a:p>
                   </a:txBody>
                   <a:tcPr anchor="ctr" marL="27432" marR="27432" marT="9144" marB="9144">
                     <a:solidFill>
-                      <a:srgbClr val="FFC000"/>
+                      <a:srgbClr val="FFFFFF"/>
                     </a:solidFill>
                   </a:tcPr>
                 </a:tc>
               </a:tr>
-              <a:tr h="230763">
+              <a:tr h="209930">
                 <a:tc>
                   <a:txBody>
-                    <a:bodyPr/>
+                    <a:bodyPr wrap="none"/>
                     <a:lstStyle/>
                     <a:p>
                       <a:pPr algn="ctr"/>
                       <a:r>
-                        <a:rPr sz="800" b="1">
+                        <a:rPr sz="600" b="1">
                           <a:solidFill>
                             <a:srgbClr val="13222D"/>
                           </a:solidFill>
                           <a:latin typeface="Arial"/>
                         </a:rPr>
-                        <a:t>RadarView</a:t>
+                        <a:t>{{EQ_PLATFORM_7}}</a:t>
                       </a:r>
                     </a:p>
                   </a:txBody>
@@ -4057,18 +4057,18 @@
                 </a:tc>
                 <a:tc>
                   <a:txBody>
-                    <a:bodyPr/>
+                    <a:bodyPr wrap="none"/>
                     <a:lstStyle/>
                     <a:p>
                       <a:pPr algn="ctr"/>
                       <a:r>
-                        <a:rPr sz="800" b="0">
+                        <a:rPr sz="600" b="0">
                           <a:solidFill>
                             <a:srgbClr val="13222D"/>
                           </a:solidFill>
                           <a:latin typeface="Arial"/>
                         </a:rPr>
-                        <a:t>cw45</a:t>
+                        <a:t>{{EQ_PLANNED_7}}</a:t>
                       </a:r>
                     </a:p>
                   </a:txBody>
@@ -4080,18 +4080,18 @@
                 </a:tc>
                 <a:tc>
                   <a:txBody>
-                    <a:bodyPr/>
+                    <a:bodyPr wrap="none"/>
                     <a:lstStyle/>
                     <a:p>
                       <a:pPr algn="ctr"/>
                       <a:r>
-                        <a:rPr sz="800" b="0">
+                        <a:rPr sz="600" b="0">
                           <a:solidFill>
                             <a:srgbClr val="13222D"/>
                           </a:solidFill>
                           <a:latin typeface="Arial"/>
                         </a:rPr>
-                        <a:t>cw45</a:t>
+                        <a:t>{{EQ_ACHIEVED_7}}</a:t>
                       </a:r>
                     </a:p>
                   </a:txBody>
@@ -4103,24 +4103,118 @@
                 </a:tc>
                 <a:tc>
                   <a:txBody>
-                    <a:bodyPr/>
+                    <a:bodyPr wrap="none"/>
                     <a:lstStyle/>
                     <a:p>
                       <a:pPr algn="ctr"/>
                       <a:r>
-                        <a:rPr sz="800" b="1">
+                        <a:rPr sz="600" b="1">
                           <a:solidFill>
                             <a:srgbClr val="13222D"/>
                           </a:solidFill>
                           <a:latin typeface="Arial"/>
                         </a:rPr>
-                        <a:t>Ready</a:t>
+                        <a:t>{{EQ_STATUS_7}}</a:t>
                       </a:r>
                     </a:p>
                   </a:txBody>
                   <a:tcPr anchor="ctr" marL="27432" marR="27432" marT="9144" marB="9144">
                     <a:solidFill>
-                      <a:srgbClr val="92D050"/>
+                      <a:srgbClr val="FFFFFF"/>
+                    </a:solidFill>
+                  </a:tcPr>
+                </a:tc>
+              </a:tr>
+              <a:tr h="209930">
+                <a:tc>
+                  <a:txBody>
+                    <a:bodyPr wrap="none"/>
+                    <a:lstStyle/>
+                    <a:p>
+                      <a:pPr algn="ctr"/>
+                      <a:r>
+                        <a:rPr sz="600" b="1">
+                          <a:solidFill>
+                            <a:srgbClr val="13222D"/>
+                          </a:solidFill>
+                          <a:latin typeface="Arial"/>
+                        </a:rPr>
+                        <a:t>{{EQ_PLATFORM_8}}</a:t>
+                      </a:r>
+                    </a:p>
+                  </a:txBody>
+                  <a:tcPr anchor="ctr" marL="27432" marR="27432" marT="9144" marB="9144">
+                    <a:solidFill>
+                      <a:srgbClr val="FFFFFF"/>
+                    </a:solidFill>
+                  </a:tcPr>
+                </a:tc>
+                <a:tc>
+                  <a:txBody>
+                    <a:bodyPr wrap="none"/>
+                    <a:lstStyle/>
+                    <a:p>
+                      <a:pPr algn="ctr"/>
+                      <a:r>
+                        <a:rPr sz="600" b="0">
+                          <a:solidFill>
+                            <a:srgbClr val="13222D"/>
+                          </a:solidFill>
+                          <a:latin typeface="Arial"/>
+                        </a:rPr>
+                        <a:t>{{EQ_PLANNED_8}}</a:t>
+                      </a:r>
+                    </a:p>
+                  </a:txBody>
+                  <a:tcPr anchor="ctr" marL="27432" marR="27432" marT="9144" marB="9144">
+                    <a:solidFill>
+                      <a:srgbClr val="FFFFFF"/>
+                    </a:solidFill>
+                  </a:tcPr>
+                </a:tc>
+                <a:tc>
+                  <a:txBody>
+                    <a:bodyPr wrap="none"/>
+                    <a:lstStyle/>
+                    <a:p>
+                      <a:pPr algn="ctr"/>
+                      <a:r>
+                        <a:rPr sz="600" b="0">
+                          <a:solidFill>
+                            <a:srgbClr val="13222D"/>
+                          </a:solidFill>
+                          <a:latin typeface="Arial"/>
+                        </a:rPr>
+                        <a:t>{{EQ_ACHIEVED_8}}</a:t>
+                      </a:r>
+                    </a:p>
+                  </a:txBody>
+                  <a:tcPr anchor="ctr" marL="27432" marR="27432" marT="9144" marB="9144">
+                    <a:solidFill>
+                      <a:srgbClr val="FFFFFF"/>
+                    </a:solidFill>
+                  </a:tcPr>
+                </a:tc>
+                <a:tc>
+                  <a:txBody>
+                    <a:bodyPr wrap="none"/>
+                    <a:lstStyle/>
+                    <a:p>
+                      <a:pPr algn="ctr"/>
+                      <a:r>
+                        <a:rPr sz="600" b="1">
+                          <a:solidFill>
+                            <a:srgbClr val="13222D"/>
+                          </a:solidFill>
+                          <a:latin typeface="Arial"/>
+                        </a:rPr>
+                        <a:t>{{EQ_STATUS_8}}</a:t>
+                      </a:r>
+                    </a:p>
+                  </a:txBody>
+                  <a:tcPr anchor="ctr" marL="27432" marR="27432" marT="9144" marB="9144">
+                    <a:solidFill>
+                      <a:srgbClr val="FFFFFF"/>
                     </a:solidFill>
                   </a:tcPr>
                 </a:tc>
@@ -4137,7 +4231,7 @@
         </p:nvSpPr>
         <p:spPr>
           <a:xfrm>
-            <a:off x="441461" y="3591255"/>
+            <a:off x="441461" y="3562410"/>
             <a:ext cx="2575192" cy="100958"/>
           </a:xfrm>
           <a:prstGeom prst="rect">
@@ -4159,7 +4253,7 @@
                 </a:solidFill>
                 <a:latin typeface="Arial"/>
               </a:rPr>
-              <a:t>Edit rows directly in the deck</a:t>
+              <a:t>Rows come from the TPM Input form; unused rows are removed</a:t>
             </a:r>
           </a:p>
         </p:txBody>

</xml_diff>